<commit_message>
corregir y ajustar algunos detalles
Para evitar malentendidos y confusiones que pudieran darse si alguien mira al esquema con ojos profesionales.
Por si no lo estaba antes, ahora queda más claro que el esquema es una simplificación generalista, para ilustrar conceptos; sin precisión "contable".
</commit_message>
<xml_diff>
--- a/documentos/esquema_basico_del_funcionamiento_economico_de_una_empresa.pptx
+++ b/documentos/esquema_basico_del_funcionamiento_economico_de_una_empresa.pptx
@@ -7,6 +7,7 @@
   <p:sldIdLst>
     <p:sldId id="256" r:id="rId2"/>
     <p:sldId id="257" r:id="rId3"/>
+    <p:sldId id="258" r:id="rId4"/>
   </p:sldIdLst>
   <p:sldSz cx="12192000" cy="6858000"/>
   <p:notesSz cx="6797675" cy="9928225"/>
@@ -244,7 +245,7 @@
           <a:p>
             <a:fld id="{2F8335AE-28F8-4460-B9C7-85D77893EB64}" type="datetimeFigureOut">
               <a:rPr lang="es-ES_tradnl" smtClean="0"/>
-              <a:t>15/03/2022</a:t>
+              <a:t>16/07/2026</a:t>
             </a:fld>
             <a:endParaRPr lang="es-ES_tradnl"/>
           </a:p>
@@ -414,7 +415,7 @@
           <a:p>
             <a:fld id="{2F8335AE-28F8-4460-B9C7-85D77893EB64}" type="datetimeFigureOut">
               <a:rPr lang="es-ES_tradnl" smtClean="0"/>
-              <a:t>15/03/2022</a:t>
+              <a:t>16/07/2026</a:t>
             </a:fld>
             <a:endParaRPr lang="es-ES_tradnl"/>
           </a:p>
@@ -594,7 +595,7 @@
           <a:p>
             <a:fld id="{2F8335AE-28F8-4460-B9C7-85D77893EB64}" type="datetimeFigureOut">
               <a:rPr lang="es-ES_tradnl" smtClean="0"/>
-              <a:t>15/03/2022</a:t>
+              <a:t>16/07/2026</a:t>
             </a:fld>
             <a:endParaRPr lang="es-ES_tradnl"/>
           </a:p>
@@ -764,7 +765,7 @@
           <a:p>
             <a:fld id="{2F8335AE-28F8-4460-B9C7-85D77893EB64}" type="datetimeFigureOut">
               <a:rPr lang="es-ES_tradnl" smtClean="0"/>
-              <a:t>15/03/2022</a:t>
+              <a:t>16/07/2026</a:t>
             </a:fld>
             <a:endParaRPr lang="es-ES_tradnl"/>
           </a:p>
@@ -1010,7 +1011,7 @@
           <a:p>
             <a:fld id="{2F8335AE-28F8-4460-B9C7-85D77893EB64}" type="datetimeFigureOut">
               <a:rPr lang="es-ES_tradnl" smtClean="0"/>
-              <a:t>15/03/2022</a:t>
+              <a:t>16/07/2026</a:t>
             </a:fld>
             <a:endParaRPr lang="es-ES_tradnl"/>
           </a:p>
@@ -1242,7 +1243,7 @@
           <a:p>
             <a:fld id="{2F8335AE-28F8-4460-B9C7-85D77893EB64}" type="datetimeFigureOut">
               <a:rPr lang="es-ES_tradnl" smtClean="0"/>
-              <a:t>15/03/2022</a:t>
+              <a:t>16/07/2026</a:t>
             </a:fld>
             <a:endParaRPr lang="es-ES_tradnl"/>
           </a:p>
@@ -1609,7 +1610,7 @@
           <a:p>
             <a:fld id="{2F8335AE-28F8-4460-B9C7-85D77893EB64}" type="datetimeFigureOut">
               <a:rPr lang="es-ES_tradnl" smtClean="0"/>
-              <a:t>15/03/2022</a:t>
+              <a:t>16/07/2026</a:t>
             </a:fld>
             <a:endParaRPr lang="es-ES_tradnl"/>
           </a:p>
@@ -1727,7 +1728,7 @@
           <a:p>
             <a:fld id="{2F8335AE-28F8-4460-B9C7-85D77893EB64}" type="datetimeFigureOut">
               <a:rPr lang="es-ES_tradnl" smtClean="0"/>
-              <a:t>15/03/2022</a:t>
+              <a:t>16/07/2026</a:t>
             </a:fld>
             <a:endParaRPr lang="es-ES_tradnl"/>
           </a:p>
@@ -1822,7 +1823,7 @@
           <a:p>
             <a:fld id="{2F8335AE-28F8-4460-B9C7-85D77893EB64}" type="datetimeFigureOut">
               <a:rPr lang="es-ES_tradnl" smtClean="0"/>
-              <a:t>15/03/2022</a:t>
+              <a:t>16/07/2026</a:t>
             </a:fld>
             <a:endParaRPr lang="es-ES_tradnl"/>
           </a:p>
@@ -2099,7 +2100,7 @@
           <a:p>
             <a:fld id="{2F8335AE-28F8-4460-B9C7-85D77893EB64}" type="datetimeFigureOut">
               <a:rPr lang="es-ES_tradnl" smtClean="0"/>
-              <a:t>15/03/2022</a:t>
+              <a:t>16/07/2026</a:t>
             </a:fld>
             <a:endParaRPr lang="es-ES_tradnl"/>
           </a:p>
@@ -2352,7 +2353,7 @@
           <a:p>
             <a:fld id="{2F8335AE-28F8-4460-B9C7-85D77893EB64}" type="datetimeFigureOut">
               <a:rPr lang="es-ES_tradnl" smtClean="0"/>
-              <a:t>15/03/2022</a:t>
+              <a:t>16/07/2026</a:t>
             </a:fld>
             <a:endParaRPr lang="es-ES_tradnl"/>
           </a:p>
@@ -2565,7 +2566,7 @@
           <a:p>
             <a:fld id="{2F8335AE-28F8-4460-B9C7-85D77893EB64}" type="datetimeFigureOut">
               <a:rPr lang="es-ES_tradnl" smtClean="0"/>
-              <a:t>15/03/2022</a:t>
+              <a:t>16/07/2026</a:t>
             </a:fld>
             <a:endParaRPr lang="es-ES_tradnl"/>
           </a:p>
@@ -3532,230 +3533,88 @@
           </p:cxnSp>
         </p:grpSp>
       </p:grpSp>
-      <p:grpSp>
-        <p:nvGrpSpPr>
-          <p:cNvPr id="107" name="Grupo 106"/>
-          <p:cNvGrpSpPr/>
+      <p:pic>
+        <p:nvPicPr>
+          <p:cNvPr id="69" name="Imagen 68"/>
+          <p:cNvPicPr>
+            <a:picLocks noChangeAspect="1"/>
+          </p:cNvPicPr>
           <p:nvPr/>
-        </p:nvGrpSpPr>
-        <p:grpSpPr>
+        </p:nvPicPr>
+        <p:blipFill>
+          <a:blip r:embed="rId4">
+            <a:extLst>
+              <a:ext uri="{28A0092B-C50C-407E-A947-70E740481C1C}">
+                <a14:useLocalDpi xmlns:a14="http://schemas.microsoft.com/office/drawing/2010/main" val="0"/>
+              </a:ext>
+            </a:extLst>
+          </a:blip>
+          <a:stretch>
+            <a:fillRect/>
+          </a:stretch>
+        </p:blipFill>
+        <p:spPr>
           <a:xfrm>
-            <a:off x="577794" y="2234033"/>
-            <a:ext cx="1959785" cy="1350901"/>
-            <a:chOff x="1074784" y="2248165"/>
-            <a:chExt cx="1959785" cy="1350901"/>
-          </a:xfrm>
-        </p:grpSpPr>
-        <p:pic>
-          <p:nvPicPr>
-            <p:cNvPr id="69" name="Imagen 68"/>
-            <p:cNvPicPr>
-              <a:picLocks noChangeAspect="1"/>
-            </p:cNvPicPr>
-            <p:nvPr/>
-          </p:nvPicPr>
-          <p:blipFill>
-            <a:blip r:embed="rId4">
-              <a:extLst>
-                <a:ext uri="{28A0092B-C50C-407E-A947-70E740481C1C}">
-                  <a14:useLocalDpi xmlns:a14="http://schemas.microsoft.com/office/drawing/2010/main" val="0"/>
-                </a:ext>
-              </a:extLst>
-            </a:blip>
-            <a:stretch>
-              <a:fillRect/>
-            </a:stretch>
-          </p:blipFill>
-          <p:spPr>
-            <a:xfrm>
-              <a:off x="2128929" y="2902741"/>
-              <a:ext cx="524301" cy="670618"/>
-            </a:xfrm>
-            <a:prstGeom prst="rect">
-              <a:avLst/>
-            </a:prstGeom>
-          </p:spPr>
-        </p:pic>
-        <p:sp>
-          <p:nvSpPr>
-            <p:cNvPr id="75" name="CuadroTexto 74"/>
-            <p:cNvSpPr txBox="1"/>
-            <p:nvPr/>
-          </p:nvSpPr>
-          <p:spPr>
-            <a:xfrm>
-              <a:off x="1074784" y="2952735"/>
-              <a:ext cx="1225174" cy="646331"/>
-            </a:xfrm>
-            <a:prstGeom prst="rect">
-              <a:avLst/>
-            </a:prstGeom>
-            <a:noFill/>
-          </p:spPr>
-          <p:txBody>
-            <a:bodyPr wrap="square" rtlCol="0">
-              <a:spAutoFit/>
-            </a:bodyPr>
-            <a:lstStyle/>
-            <a:p>
-              <a:pPr algn="ctr"/>
-              <a:r>
-                <a:rPr lang="en-US" dirty="0" err="1" smtClean="0"/>
-                <a:t>capitales</a:t>
-              </a:r>
-              <a:r>
-                <a:rPr lang="en-US" dirty="0" smtClean="0"/>
-                <a:t/>
-              </a:r>
-              <a:br>
-                <a:rPr lang="en-US" dirty="0" smtClean="0"/>
-              </a:br>
-              <a:r>
-                <a:rPr lang="en-US" dirty="0" err="1" smtClean="0"/>
-                <a:t>externos</a:t>
-              </a:r>
-              <a:endParaRPr lang="es-ES_tradnl" dirty="0"/>
-            </a:p>
-          </p:txBody>
-        </p:sp>
-        <p:sp>
-          <p:nvSpPr>
-            <p:cNvPr id="102" name="Nube 101"/>
-            <p:cNvSpPr/>
-            <p:nvPr/>
-          </p:nvSpPr>
-          <p:spPr>
-            <a:xfrm>
-              <a:off x="1499536" y="2248165"/>
-              <a:ext cx="1535033" cy="400900"/>
-            </a:xfrm>
-            <a:prstGeom prst="cloud">
-              <a:avLst/>
-            </a:prstGeom>
-          </p:spPr>
-          <p:style>
-            <a:lnRef idx="2">
-              <a:schemeClr val="accent1">
-                <a:shade val="50000"/>
-              </a:schemeClr>
-            </a:lnRef>
-            <a:fillRef idx="1">
-              <a:schemeClr val="accent1"/>
-            </a:fillRef>
-            <a:effectRef idx="0">
-              <a:schemeClr val="accent1"/>
-            </a:effectRef>
-            <a:fontRef idx="minor">
-              <a:schemeClr val="lt1"/>
-            </a:fontRef>
-          </p:style>
-          <p:txBody>
-            <a:bodyPr rtlCol="0" anchor="ctr"/>
-            <a:lstStyle/>
-            <a:p>
-              <a:pPr algn="ctr"/>
-              <a:r>
-                <a:rPr lang="en-US" sz="1200" dirty="0" err="1" smtClean="0"/>
-                <a:t>Inversores</a:t>
-              </a:r>
-              <a:r>
-                <a:rPr lang="en-US" sz="1200" dirty="0" smtClean="0"/>
-                <a:t> y </a:t>
-              </a:r>
-              <a:r>
-                <a:rPr lang="en-US" sz="1200" dirty="0" err="1" smtClean="0"/>
-                <a:t>prestamistas</a:t>
-              </a:r>
-              <a:endParaRPr lang="es-ES_tradnl" sz="1200" dirty="0"/>
-            </a:p>
-          </p:txBody>
-        </p:sp>
-      </p:grpSp>
-      <p:grpSp>
-        <p:nvGrpSpPr>
-          <p:cNvPr id="105" name="Grupo 104"/>
-          <p:cNvGrpSpPr/>
+            <a:off x="1631939" y="2888609"/>
+            <a:ext cx="524301" cy="670618"/>
+          </a:xfrm>
+          <a:prstGeom prst="rect">
+            <a:avLst/>
+          </a:prstGeom>
+        </p:spPr>
+      </p:pic>
+      <p:sp>
+        <p:nvSpPr>
+          <p:cNvPr id="75" name="CuadroTexto 74"/>
+          <p:cNvSpPr txBox="1"/>
           <p:nvPr/>
-        </p:nvGrpSpPr>
-        <p:grpSpPr>
+        </p:nvSpPr>
+        <p:spPr>
           <a:xfrm>
-            <a:off x="8896785" y="5100088"/>
-            <a:ext cx="1482863" cy="1348652"/>
-            <a:chOff x="8001768" y="4459579"/>
-            <a:chExt cx="1482863" cy="1348652"/>
-          </a:xfrm>
-        </p:grpSpPr>
-        <p:pic>
-          <p:nvPicPr>
-            <p:cNvPr id="5" name="Imagen 4" descr="Free photo: Water Pump, Industrial, Industry - Free Image ..."/>
-            <p:cNvPicPr>
-              <a:picLocks noChangeAspect="1"/>
-            </p:cNvPicPr>
-            <p:nvPr/>
-          </p:nvPicPr>
-          <p:blipFill>
-            <a:blip r:embed="rId3">
-              <a:extLst>
-                <a:ext uri="{28A0092B-C50C-407E-A947-70E740481C1C}">
-                  <a14:useLocalDpi xmlns:a14="http://schemas.microsoft.com/office/drawing/2010/main" val="0"/>
-                </a:ext>
-              </a:extLst>
-            </a:blip>
-            <a:stretch>
-              <a:fillRect/>
-            </a:stretch>
-          </p:blipFill>
-          <p:spPr>
-            <a:xfrm>
-              <a:off x="8001768" y="4459579"/>
-              <a:ext cx="1482863" cy="988575"/>
-            </a:xfrm>
-            <a:prstGeom prst="rect">
-              <a:avLst/>
-            </a:prstGeom>
-          </p:spPr>
-        </p:pic>
-        <p:sp>
-          <p:nvSpPr>
-            <p:cNvPr id="104" name="CuadroTexto 103"/>
-            <p:cNvSpPr txBox="1"/>
-            <p:nvPr/>
-          </p:nvSpPr>
-          <p:spPr>
-            <a:xfrm>
-              <a:off x="8307024" y="5438899"/>
-              <a:ext cx="796244" cy="369332"/>
-            </a:xfrm>
-            <a:prstGeom prst="rect">
-              <a:avLst/>
-            </a:prstGeom>
-            <a:noFill/>
-          </p:spPr>
-          <p:txBody>
-            <a:bodyPr wrap="none" rtlCol="0">
-              <a:spAutoFit/>
-            </a:bodyPr>
-            <a:lstStyle/>
-            <a:p>
-              <a:r>
-                <a:rPr lang="en-US" dirty="0" err="1" smtClean="0"/>
-                <a:t>ventas</a:t>
-              </a:r>
-              <a:endParaRPr lang="es-ES_tradnl" dirty="0"/>
-            </a:p>
-          </p:txBody>
-        </p:sp>
-      </p:grpSp>
-      <p:sp>
-        <p:nvSpPr>
-          <p:cNvPr id="103" name="Nube 102"/>
+            <a:off x="577794" y="2938603"/>
+            <a:ext cx="1225174" cy="646331"/>
+          </a:xfrm>
+          <a:prstGeom prst="rect">
+            <a:avLst/>
+          </a:prstGeom>
+          <a:noFill/>
+        </p:spPr>
+        <p:txBody>
+          <a:bodyPr wrap="square" rtlCol="0">
+            <a:spAutoFit/>
+          </a:bodyPr>
+          <a:lstStyle/>
+          <a:p>
+            <a:pPr algn="ctr"/>
+            <a:r>
+              <a:rPr lang="en-US" dirty="0" err="1" smtClean="0"/>
+              <a:t>capitales</a:t>
+            </a:r>
+            <a:r>
+              <a:rPr lang="en-US" dirty="0" smtClean="0"/>
+              <a:t/>
+            </a:r>
+            <a:br>
+              <a:rPr lang="en-US" dirty="0" smtClean="0"/>
+            </a:br>
+            <a:r>
+              <a:rPr lang="en-US" dirty="0" err="1" smtClean="0"/>
+              <a:t>externos</a:t>
+            </a:r>
+            <a:endParaRPr lang="es-ES_tradnl" dirty="0"/>
+          </a:p>
+        </p:txBody>
+      </p:sp>
+      <p:sp>
+        <p:nvSpPr>
+          <p:cNvPr id="102" name="Nube 101"/>
           <p:cNvSpPr/>
           <p:nvPr/>
         </p:nvSpPr>
         <p:spPr>
           <a:xfrm>
-            <a:off x="10275325" y="5440443"/>
-            <a:ext cx="1808804" cy="1211164"/>
+            <a:off x="1002546" y="2083064"/>
+            <a:ext cx="1535033" cy="551869"/>
           </a:xfrm>
           <a:prstGeom prst="cloud">
             <a:avLst/>
@@ -3783,6 +3642,118 @@
           <a:p>
             <a:pPr algn="ctr"/>
             <a:r>
+              <a:rPr lang="en-US" sz="1200" dirty="0" err="1" smtClean="0"/>
+              <a:t>Inversores</a:t>
+            </a:r>
+            <a:r>
+              <a:rPr lang="en-US" sz="1200" dirty="0" smtClean="0"/>
+              <a:t> y </a:t>
+            </a:r>
+            <a:r>
+              <a:rPr lang="en-US" sz="1200" dirty="0" err="1" smtClean="0"/>
+              <a:t>prestamistas</a:t>
+            </a:r>
+            <a:endParaRPr lang="es-ES_tradnl" sz="1200" dirty="0"/>
+          </a:p>
+        </p:txBody>
+      </p:sp>
+      <p:pic>
+        <p:nvPicPr>
+          <p:cNvPr id="5" name="Imagen 4" descr="Free photo: Water Pump, Industrial, Industry - Free Image ..."/>
+          <p:cNvPicPr>
+            <a:picLocks noChangeAspect="1"/>
+          </p:cNvPicPr>
+          <p:nvPr/>
+        </p:nvPicPr>
+        <p:blipFill>
+          <a:blip r:embed="rId3">
+            <a:extLst>
+              <a:ext uri="{28A0092B-C50C-407E-A947-70E740481C1C}">
+                <a14:useLocalDpi xmlns:a14="http://schemas.microsoft.com/office/drawing/2010/main" val="0"/>
+              </a:ext>
+            </a:extLst>
+          </a:blip>
+          <a:stretch>
+            <a:fillRect/>
+          </a:stretch>
+        </p:blipFill>
+        <p:spPr>
+          <a:xfrm>
+            <a:off x="8896785" y="5100088"/>
+            <a:ext cx="1482863" cy="988575"/>
+          </a:xfrm>
+          <a:prstGeom prst="rect">
+            <a:avLst/>
+          </a:prstGeom>
+        </p:spPr>
+      </p:pic>
+      <p:sp>
+        <p:nvSpPr>
+          <p:cNvPr id="104" name="CuadroTexto 103"/>
+          <p:cNvSpPr txBox="1"/>
+          <p:nvPr/>
+        </p:nvSpPr>
+        <p:spPr>
+          <a:xfrm>
+            <a:off x="10200435" y="5179049"/>
+            <a:ext cx="796244" cy="369332"/>
+          </a:xfrm>
+          <a:prstGeom prst="rect">
+            <a:avLst/>
+          </a:prstGeom>
+          <a:noFill/>
+        </p:spPr>
+        <p:txBody>
+          <a:bodyPr wrap="none" rtlCol="0">
+            <a:spAutoFit/>
+          </a:bodyPr>
+          <a:lstStyle/>
+          <a:p>
+            <a:r>
+              <a:rPr lang="en-US" dirty="0" err="1" smtClean="0"/>
+              <a:t>ventas</a:t>
+            </a:r>
+            <a:endParaRPr lang="es-ES_tradnl" dirty="0"/>
+          </a:p>
+        </p:txBody>
+      </p:sp>
+      <p:sp>
+        <p:nvSpPr>
+          <p:cNvPr id="103" name="Nube 102"/>
+          <p:cNvSpPr/>
+          <p:nvPr/>
+        </p:nvSpPr>
+        <p:spPr>
+          <a:xfrm>
+            <a:off x="10174238" y="5562869"/>
+            <a:ext cx="1808804" cy="1211164"/>
+          </a:xfrm>
+          <a:prstGeom prst="cloud">
+            <a:avLst/>
+          </a:prstGeom>
+        </p:spPr>
+        <p:style>
+          <a:lnRef idx="2">
+            <a:schemeClr val="accent1">
+              <a:shade val="50000"/>
+            </a:schemeClr>
+          </a:lnRef>
+          <a:fillRef idx="1">
+            <a:schemeClr val="accent1"/>
+          </a:fillRef>
+          <a:effectRef idx="0">
+            <a:schemeClr val="accent1"/>
+          </a:effectRef>
+          <a:fontRef idx="minor">
+            <a:schemeClr val="lt1"/>
+          </a:fontRef>
+        </p:style>
+        <p:txBody>
+          <a:bodyPr rtlCol="0" anchor="ctr"/>
+          <a:lstStyle/>
+          <a:p>
+            <a:pPr algn="ctr"/>
+            <a:r>
               <a:rPr lang="en-US" dirty="0" err="1" smtClean="0"/>
               <a:t>mercado</a:t>
             </a:r>
@@ -3793,15 +3764,13 @@
       <p:cxnSp>
         <p:nvCxnSpPr>
           <p:cNvPr id="113" name="Conector recto 112"/>
-          <p:cNvCxnSpPr>
-            <a:endCxn id="5" idx="3"/>
-          </p:cNvCxnSpPr>
+          <p:cNvCxnSpPr/>
           <p:nvPr/>
         </p:nvCxnSpPr>
         <p:spPr>
           <a:xfrm flipH="1">
-            <a:off x="10379648" y="3744658"/>
-            <a:ext cx="1211049" cy="1849718"/>
+            <a:off x="10566582" y="3744658"/>
+            <a:ext cx="1024116" cy="1377030"/>
           </a:xfrm>
           <a:prstGeom prst="line">
             <a:avLst/>
@@ -3945,39 +3914,6 @@
             <a:headEnd type="none" w="sm" len="sm"/>
             <a:tailEnd type="stealth" w="sm" len="sm"/>
           </a:ln>
-        </p:spPr>
-        <p:style>
-          <a:lnRef idx="1">
-            <a:schemeClr val="accent1"/>
-          </a:lnRef>
-          <a:fillRef idx="0">
-            <a:schemeClr val="accent1"/>
-          </a:fillRef>
-          <a:effectRef idx="0">
-            <a:schemeClr val="accent1"/>
-          </a:effectRef>
-          <a:fontRef idx="minor">
-            <a:schemeClr val="tx1"/>
-          </a:fontRef>
-        </p:style>
-      </p:cxnSp>
-      <p:cxnSp>
-        <p:nvCxnSpPr>
-          <p:cNvPr id="126" name="Conector recto 125"/>
-          <p:cNvCxnSpPr>
-            <a:endCxn id="5" idx="1"/>
-          </p:cNvCxnSpPr>
-          <p:nvPr/>
-        </p:nvCxnSpPr>
-        <p:spPr>
-          <a:xfrm>
-            <a:off x="8862625" y="4789096"/>
-            <a:ext cx="34160" cy="805280"/>
-          </a:xfrm>
-          <a:prstGeom prst="line">
-            <a:avLst/>
-          </a:prstGeom>
-          <a:ln w="127000"/>
         </p:spPr>
         <p:style>
           <a:lnRef idx="1">
@@ -4300,8 +4236,8 @@
         </p:nvCxnSpPr>
         <p:spPr>
           <a:xfrm flipV="1">
-            <a:off x="513800" y="2434483"/>
-            <a:ext cx="493507" cy="91278"/>
+            <a:off x="513800" y="2358999"/>
+            <a:ext cx="493507" cy="166762"/>
           </a:xfrm>
           <a:prstGeom prst="line">
             <a:avLst/>
@@ -4500,8 +4436,8 @@
         </p:nvSpPr>
         <p:spPr>
           <a:xfrm>
-            <a:off x="10062136" y="1371398"/>
-            <a:ext cx="1412952" cy="923330"/>
+            <a:off x="10204425" y="1436733"/>
+            <a:ext cx="1205098" cy="646331"/>
           </a:xfrm>
           <a:prstGeom prst="rect">
             <a:avLst/>
@@ -4509,7 +4445,7 @@
           <a:noFill/>
         </p:spPr>
         <p:txBody>
-          <a:bodyPr wrap="none" rtlCol="0">
+          <a:bodyPr wrap="square" rtlCol="0">
             <a:spAutoFit/>
           </a:bodyPr>
           <a:lstStyle/>
@@ -4523,7 +4459,7 @@
                   </a:schemeClr>
                 </a:solidFill>
               </a:rPr>
-              <a:t>t</a:t>
+              <a:t>c</a:t>
             </a:r>
             <a:r>
               <a:rPr lang="en-US" dirty="0" err="1" smtClean="0">
@@ -4533,67 +4469,27 @@
                   </a:schemeClr>
                 </a:solidFill>
               </a:rPr>
-              <a:t>ransferencia</a:t>
-            </a:r>
-            <a:endParaRPr lang="en-US" dirty="0" smtClean="0">
-              <a:solidFill>
-                <a:schemeClr val="accent6">
-                  <a:lumMod val="75000"/>
-                </a:schemeClr>
-              </a:solidFill>
-            </a:endParaRPr>
-          </a:p>
-          <a:p>
-            <a:pPr algn="ctr"/>
-            <a:r>
-              <a:rPr lang="en-US" dirty="0" err="1" smtClean="0">
+              <a:t>aja</a:t>
+            </a:r>
+            <a:r>
+              <a:rPr lang="en-US" dirty="0" smtClean="0">
                 <a:solidFill>
                   <a:schemeClr val="accent6">
                     <a:lumMod val="75000"/>
                   </a:schemeClr>
                 </a:solidFill>
               </a:rPr>
-              <a:t>efectiva</a:t>
-            </a:r>
-            <a:endParaRPr lang="en-US" dirty="0" smtClean="0">
-              <a:solidFill>
-                <a:schemeClr val="accent6">
-                  <a:lumMod val="75000"/>
-                </a:schemeClr>
-              </a:solidFill>
-            </a:endParaRPr>
-          </a:p>
-          <a:p>
-            <a:pPr algn="ctr"/>
-            <a:r>
-              <a:rPr lang="en-US" dirty="0" smtClean="0">
+              <a:t> </a:t>
+            </a:r>
+            <a:r>
+              <a:rPr lang="en-US" dirty="0" err="1" smtClean="0">
                 <a:solidFill>
                   <a:schemeClr val="accent6">
                     <a:lumMod val="75000"/>
                   </a:schemeClr>
                 </a:solidFill>
               </a:rPr>
-              <a:t>(</a:t>
-            </a:r>
-            <a:r>
-              <a:rPr lang="en-US" sz="1400" dirty="0" smtClean="0">
-                <a:solidFill>
-                  <a:schemeClr val="accent6">
-                    <a:lumMod val="75000"/>
-                  </a:schemeClr>
-                </a:solidFill>
-              </a:rPr>
-              <a:t>throughput</a:t>
-            </a:r>
-            <a:r>
-              <a:rPr lang="en-US" dirty="0" smtClean="0">
-                <a:solidFill>
-                  <a:schemeClr val="accent6">
-                    <a:lumMod val="75000"/>
-                  </a:schemeClr>
-                </a:solidFill>
-              </a:rPr>
-              <a:t>)</a:t>
+              <a:t>entrante</a:t>
             </a:r>
             <a:endParaRPr lang="es-ES_tradnl" dirty="0">
               <a:solidFill>
@@ -4701,7 +4597,7 @@
         </p:nvSpPr>
         <p:spPr>
           <a:xfrm>
-            <a:off x="8922982" y="4797464"/>
+            <a:off x="8973488" y="4752356"/>
             <a:ext cx="490840" cy="369332"/>
           </a:xfrm>
           <a:prstGeom prst="rect">
@@ -4845,8 +4741,8 @@
           </p:sp>
         </mc:Fallback>
       </mc:AlternateContent>
-      <mc:AlternateContent xmlns:mc="http://schemas.openxmlformats.org/markup-compatibility/2006" xmlns:a14="http://schemas.microsoft.com/office/drawing/2010/main">
-        <mc:Choice Requires="a14">
+      <mc:AlternateContent xmlns:mc="http://schemas.openxmlformats.org/markup-compatibility/2006">
+        <mc:Choice xmlns:a14="http://schemas.microsoft.com/office/drawing/2010/main" Requires="a14">
           <p:sp>
             <p:nvSpPr>
               <p:cNvPr id="238" name="CuadroTexto 237"/>
@@ -4855,8 +4751,8 @@
             </p:nvSpPr>
             <p:spPr>
               <a:xfrm>
-                <a:off x="1157408" y="5469712"/>
-                <a:ext cx="3066659" cy="485454"/>
+                <a:off x="1157409" y="5469711"/>
+                <a:ext cx="3065013" cy="485454"/>
               </a:xfrm>
               <a:prstGeom prst="rect">
                 <a:avLst/>
@@ -4921,7 +4817,7 @@
             </p:txBody>
           </p:sp>
         </mc:Choice>
-        <mc:Fallback xmlns="">
+        <mc:Fallback>
           <p:sp>
             <p:nvSpPr>
               <p:cNvPr id="238" name="CuadroTexto 237"/>
@@ -4932,8 +4828,8 @@
             </p:nvSpPr>
             <p:spPr>
               <a:xfrm>
-                <a:off x="1157408" y="5469712"/>
-                <a:ext cx="3066659" cy="485454"/>
+                <a:off x="1157409" y="5469711"/>
+                <a:ext cx="3065013" cy="485454"/>
               </a:xfrm>
               <a:prstGeom prst="rect">
                 <a:avLst/>
@@ -4950,7 +4846,7 @@
               <a:lstStyle/>
               <a:p>
                 <a:r>
-                  <a:rPr lang="es-ES_tradnl">
+                  <a:rPr lang="es-ES">
                     <a:noFill/>
                   </a:rPr>
                   <a:t> </a:t>
@@ -4968,7 +4864,7 @@
         </p:nvSpPr>
         <p:spPr>
           <a:xfrm>
-            <a:off x="10383838" y="4512740"/>
+            <a:off x="10088392" y="4716268"/>
             <a:ext cx="478190" cy="369332"/>
           </a:xfrm>
           <a:prstGeom prst="rect">
@@ -5284,7 +5180,7 @@
         </p:nvSpPr>
         <p:spPr>
           <a:xfrm>
-            <a:off x="7948954" y="3262051"/>
+            <a:off x="7808119" y="3296635"/>
             <a:ext cx="1222001" cy="369332"/>
           </a:xfrm>
           <a:prstGeom prst="rect">
@@ -5316,6 +5212,78 @@
                 </a:schemeClr>
               </a:solidFill>
             </a:endParaRPr>
+          </a:p>
+        </p:txBody>
+      </p:sp>
+      <p:cxnSp>
+        <p:nvCxnSpPr>
+          <p:cNvPr id="63" name="Conector recto 62"/>
+          <p:cNvCxnSpPr/>
+          <p:nvPr/>
+        </p:nvCxnSpPr>
+        <p:spPr>
+          <a:xfrm>
+            <a:off x="8864696" y="4848284"/>
+            <a:ext cx="58286" cy="592159"/>
+          </a:xfrm>
+          <a:prstGeom prst="line">
+            <a:avLst/>
+          </a:prstGeom>
+          <a:ln w="165100">
+            <a:headEnd type="none" w="sm" len="sm"/>
+            <a:tailEnd type="stealth" w="sm" len="sm"/>
+          </a:ln>
+        </p:spPr>
+        <p:style>
+          <a:lnRef idx="1">
+            <a:schemeClr val="accent1"/>
+          </a:lnRef>
+          <a:fillRef idx="0">
+            <a:schemeClr val="accent1"/>
+          </a:fillRef>
+          <a:effectRef idx="0">
+            <a:schemeClr val="accent1"/>
+          </a:effectRef>
+          <a:fontRef idx="minor">
+            <a:schemeClr val="tx1"/>
+          </a:fontRef>
+        </p:style>
+      </p:cxnSp>
+      <p:sp>
+        <p:nvSpPr>
+          <p:cNvPr id="11" name="CuadroTexto 10"/>
+          <p:cNvSpPr txBox="1"/>
+          <p:nvPr/>
+        </p:nvSpPr>
+        <p:spPr>
+          <a:xfrm>
+            <a:off x="3807290" y="6352715"/>
+            <a:ext cx="4503630" cy="400110"/>
+          </a:xfrm>
+          <a:prstGeom prst="rect">
+            <a:avLst/>
+          </a:prstGeom>
+          <a:noFill/>
+        </p:spPr>
+        <p:txBody>
+          <a:bodyPr wrap="square" rtlCol="0">
+            <a:spAutoFit/>
+          </a:bodyPr>
+          <a:lstStyle/>
+          <a:p>
+            <a:r>
+              <a:rPr lang="es-ES" sz="1000" dirty="0" smtClean="0"/>
+              <a:t>Nota: las fórmulas de `resultado neto` y `retorno de inversión` están simplificadas, no se contemplan efectos detallados de </a:t>
+            </a:r>
+            <a:r>
+              <a:rPr lang="es-ES" sz="1000" dirty="0" err="1" smtClean="0"/>
+              <a:t>periodificación</a:t>
+            </a:r>
+            <a:r>
+              <a:rPr lang="es-ES" sz="1000" dirty="0" smtClean="0"/>
+              <a:t> en su tratamiento contable.</a:t>
+            </a:r>
+            <a:endParaRPr lang="es-ES" sz="1000" dirty="0"/>
           </a:p>
         </p:txBody>
       </p:sp>
@@ -7125,6 +7093,446 @@
     <p:extLst>
       <p:ext uri="{BB962C8B-B14F-4D97-AF65-F5344CB8AC3E}">
         <p14:creationId xmlns:p14="http://schemas.microsoft.com/office/powerpoint/2010/main" val="3418621708"/>
+      </p:ext>
+    </p:extLst>
+  </p:cSld>
+  <p:clrMapOvr>
+    <a:masterClrMapping/>
+  </p:clrMapOvr>
+  <p:timing>
+    <p:tnLst>
+      <p:par>
+        <p:cTn id="1" dur="indefinite" restart="never" nodeType="tmRoot"/>
+      </p:par>
+    </p:tnLst>
+  </p:timing>
+</p:sld>
+</file>
+
+<file path=ppt/slides/slide3.xml><?xml version="1.0" encoding="utf-8"?>
+<p:sld xmlns:a="http://schemas.openxmlformats.org/drawingml/2006/main" xmlns:r="http://schemas.openxmlformats.org/officeDocument/2006/relationships" xmlns:p="http://schemas.openxmlformats.org/presentationml/2006/main">
+  <p:cSld>
+    <p:spTree>
+      <p:nvGrpSpPr>
+        <p:cNvPr id="1" name=""/>
+        <p:cNvGrpSpPr/>
+        <p:nvPr/>
+      </p:nvGrpSpPr>
+      <p:grpSpPr>
+        <a:xfrm>
+          <a:off x="0" y="0"/>
+          <a:ext cx="0" cy="0"/>
+          <a:chOff x="0" y="0"/>
+          <a:chExt cx="0" cy="0"/>
+        </a:xfrm>
+      </p:grpSpPr>
+      <p:sp>
+        <p:nvSpPr>
+          <p:cNvPr id="2" name="Título 1"/>
+          <p:cNvSpPr>
+            <a:spLocks noGrp="1"/>
+          </p:cNvSpPr>
+          <p:nvPr>
+            <p:ph type="title"/>
+          </p:nvPr>
+        </p:nvSpPr>
+        <p:spPr/>
+        <p:txBody>
+          <a:bodyPr>
+            <a:noAutofit/>
+          </a:bodyPr>
+          <a:lstStyle/>
+          <a:p>
+            <a:pPr algn="ctr"/>
+            <a:r>
+              <a:rPr lang="es-ES" sz="3200" dirty="0" smtClean="0"/>
+              <a:t>Diferencia </a:t>
+            </a:r>
+            <a:r>
+              <a:rPr lang="es-ES" sz="3200" dirty="0"/>
+              <a:t>entre FINANZAS y CONTABILIDAD</a:t>
+            </a:r>
+          </a:p>
+        </p:txBody>
+      </p:sp>
+      <p:sp>
+        <p:nvSpPr>
+          <p:cNvPr id="3" name="Marcador de contenido 2"/>
+          <p:cNvSpPr>
+            <a:spLocks noGrp="1"/>
+          </p:cNvSpPr>
+          <p:nvPr>
+            <p:ph idx="1"/>
+          </p:nvPr>
+        </p:nvSpPr>
+        <p:spPr>
+          <a:xfrm>
+            <a:off x="1772194" y="1690688"/>
+            <a:ext cx="8752113" cy="2441575"/>
+          </a:xfrm>
+        </p:spPr>
+        <p:txBody>
+          <a:bodyPr>
+            <a:normAutofit fontScale="25000" lnSpcReduction="20000"/>
+          </a:bodyPr>
+          <a:lstStyle/>
+          <a:p>
+            <a:pPr marL="180000" indent="-180000">
+              <a:lnSpc>
+                <a:spcPct val="170000"/>
+              </a:lnSpc>
+            </a:pPr>
+            <a:r>
+              <a:rPr lang="es-ES" sz="7200" dirty="0">
+                <a:latin typeface="Arial" panose="020B0604020202020204" pitchFamily="34" charset="0"/>
+                <a:cs typeface="Arial" panose="020B0604020202020204" pitchFamily="34" charset="0"/>
+              </a:rPr>
+              <a:t>Finanzas</a:t>
+            </a:r>
+            <a:r>
+              <a:rPr lang="es-ES" sz="7200" dirty="0" smtClean="0">
+                <a:latin typeface="Arial" panose="020B0604020202020204" pitchFamily="34" charset="0"/>
+                <a:cs typeface="Arial" panose="020B0604020202020204" pitchFamily="34" charset="0"/>
+              </a:rPr>
+              <a:t>:</a:t>
+            </a:r>
+            <a:r>
+              <a:rPr lang="es-ES" sz="4500" dirty="0" smtClean="0">
+                <a:latin typeface="Times New Roman" panose="02020603050405020304" pitchFamily="18" charset="0"/>
+                <a:cs typeface="Times New Roman" panose="02020603050405020304" pitchFamily="18" charset="0"/>
+              </a:rPr>
+              <a:t/>
+            </a:r>
+            <a:br>
+              <a:rPr lang="es-ES" sz="4500" dirty="0" smtClean="0">
+                <a:latin typeface="Times New Roman" panose="02020603050405020304" pitchFamily="18" charset="0"/>
+                <a:cs typeface="Times New Roman" panose="02020603050405020304" pitchFamily="18" charset="0"/>
+              </a:rPr>
+            </a:br>
+            <a:r>
+              <a:rPr lang="es-ES" sz="5600" dirty="0" smtClean="0">
+                <a:latin typeface="Times New Roman" panose="02020603050405020304" pitchFamily="18" charset="0"/>
+                <a:cs typeface="Times New Roman" panose="02020603050405020304" pitchFamily="18" charset="0"/>
+              </a:rPr>
+              <a:t>Realización </a:t>
+            </a:r>
+            <a:r>
+              <a:rPr lang="es-ES" sz="5600" dirty="0">
+                <a:latin typeface="Times New Roman" panose="02020603050405020304" pitchFamily="18" charset="0"/>
+                <a:cs typeface="Times New Roman" panose="02020603050405020304" pitchFamily="18" charset="0"/>
+              </a:rPr>
+              <a:t>de los movimientos de dinero, según este se mueve en la realidad.</a:t>
+            </a:r>
+          </a:p>
+          <a:p>
+            <a:endParaRPr lang="es-ES" sz="4500" dirty="0">
+              <a:latin typeface="Times New Roman" panose="02020603050405020304" pitchFamily="18" charset="0"/>
+              <a:cs typeface="Times New Roman" panose="02020603050405020304" pitchFamily="18" charset="0"/>
+            </a:endParaRPr>
+          </a:p>
+          <a:p>
+            <a:pPr marL="180000" indent="-180000">
+              <a:lnSpc>
+                <a:spcPct val="170000"/>
+              </a:lnSpc>
+            </a:pPr>
+            <a:r>
+              <a:rPr lang="es-ES" sz="7200" dirty="0">
+                <a:latin typeface="Arial" panose="020B0604020202020204" pitchFamily="34" charset="0"/>
+                <a:cs typeface="Arial" panose="020B0604020202020204" pitchFamily="34" charset="0"/>
+              </a:rPr>
+              <a:t>Contabilidad: </a:t>
+            </a:r>
+            <a:r>
+              <a:rPr lang="es-ES" sz="4500" dirty="0" smtClean="0">
+                <a:latin typeface="Times New Roman" panose="02020603050405020304" pitchFamily="18" charset="0"/>
+                <a:cs typeface="Times New Roman" panose="02020603050405020304" pitchFamily="18" charset="0"/>
+              </a:rPr>
+              <a:t/>
+            </a:r>
+            <a:br>
+              <a:rPr lang="es-ES" sz="4500" dirty="0" smtClean="0">
+                <a:latin typeface="Times New Roman" panose="02020603050405020304" pitchFamily="18" charset="0"/>
+                <a:cs typeface="Times New Roman" panose="02020603050405020304" pitchFamily="18" charset="0"/>
+              </a:rPr>
+            </a:br>
+            <a:r>
+              <a:rPr lang="es-ES" sz="5600" dirty="0" smtClean="0">
+                <a:latin typeface="Times New Roman" panose="02020603050405020304" pitchFamily="18" charset="0"/>
+                <a:cs typeface="Times New Roman" panose="02020603050405020304" pitchFamily="18" charset="0"/>
+              </a:rPr>
+              <a:t>Registro </a:t>
+            </a:r>
+            <a:r>
+              <a:rPr lang="es-ES" sz="5600" dirty="0">
+                <a:latin typeface="Times New Roman" panose="02020603050405020304" pitchFamily="18" charset="0"/>
+                <a:cs typeface="Times New Roman" panose="02020603050405020304" pitchFamily="18" charset="0"/>
+              </a:rPr>
+              <a:t>legal de los movimientos de dinero, siguiendo reglas preestablecidas, iguales para todos, </a:t>
+            </a:r>
+            <a:r>
+              <a:rPr lang="es-ES" sz="5600" dirty="0" smtClean="0">
+                <a:latin typeface="Times New Roman" panose="02020603050405020304" pitchFamily="18" charset="0"/>
+                <a:cs typeface="Times New Roman" panose="02020603050405020304" pitchFamily="18" charset="0"/>
+              </a:rPr>
+              <a:t/>
+            </a:r>
+            <a:br>
+              <a:rPr lang="es-ES" sz="5600" dirty="0" smtClean="0">
+                <a:latin typeface="Times New Roman" panose="02020603050405020304" pitchFamily="18" charset="0"/>
+                <a:cs typeface="Times New Roman" panose="02020603050405020304" pitchFamily="18" charset="0"/>
+              </a:rPr>
+            </a:br>
+            <a:r>
+              <a:rPr lang="es-ES" sz="5600" dirty="0" smtClean="0">
+                <a:latin typeface="Times New Roman" panose="02020603050405020304" pitchFamily="18" charset="0"/>
+                <a:cs typeface="Times New Roman" panose="02020603050405020304" pitchFamily="18" charset="0"/>
+              </a:rPr>
+              <a:t>para </a:t>
+            </a:r>
+            <a:r>
+              <a:rPr lang="es-ES" sz="5600" dirty="0">
+                <a:latin typeface="Times New Roman" panose="02020603050405020304" pitchFamily="18" charset="0"/>
+                <a:cs typeface="Times New Roman" panose="02020603050405020304" pitchFamily="18" charset="0"/>
+              </a:rPr>
+              <a:t>calcular, a posteriori, repartos legales tales como los impuestos, los dividendos, la valoración de la empresa,...</a:t>
+            </a:r>
+          </a:p>
+          <a:p>
+            <a:endParaRPr lang="es-ES" dirty="0"/>
+          </a:p>
+        </p:txBody>
+      </p:sp>
+      <p:cxnSp>
+        <p:nvCxnSpPr>
+          <p:cNvPr id="5" name="Conector recto 4"/>
+          <p:cNvCxnSpPr/>
+          <p:nvPr/>
+        </p:nvCxnSpPr>
+        <p:spPr>
+          <a:xfrm flipV="1">
+            <a:off x="2124891" y="1349829"/>
+            <a:ext cx="8046720" cy="43542"/>
+          </a:xfrm>
+          <a:prstGeom prst="line">
+            <a:avLst/>
+          </a:prstGeom>
+        </p:spPr>
+        <p:style>
+          <a:lnRef idx="1">
+            <a:schemeClr val="accent1"/>
+          </a:lnRef>
+          <a:fillRef idx="0">
+            <a:schemeClr val="accent1"/>
+          </a:fillRef>
+          <a:effectRef idx="0">
+            <a:schemeClr val="accent1"/>
+          </a:effectRef>
+          <a:fontRef idx="minor">
+            <a:schemeClr val="tx1"/>
+          </a:fontRef>
+        </p:style>
+      </p:cxnSp>
+      <p:sp>
+        <p:nvSpPr>
+          <p:cNvPr id="7" name="CuadroTexto 6"/>
+          <p:cNvSpPr txBox="1"/>
+          <p:nvPr/>
+        </p:nvSpPr>
+        <p:spPr>
+          <a:xfrm>
+            <a:off x="838200" y="4267200"/>
+            <a:ext cx="10515600" cy="2616101"/>
+          </a:xfrm>
+          <a:prstGeom prst="rect">
+            <a:avLst/>
+          </a:prstGeom>
+          <a:noFill/>
+        </p:spPr>
+        <p:txBody>
+          <a:bodyPr wrap="square" rtlCol="0">
+            <a:spAutoFit/>
+          </a:bodyPr>
+          <a:lstStyle/>
+          <a:p>
+            <a:r>
+              <a:rPr lang="es-ES" sz="1200" dirty="0" smtClean="0">
+                <a:latin typeface="Times New Roman" panose="02020603050405020304" pitchFamily="18" charset="0"/>
+                <a:cs typeface="Times New Roman" panose="02020603050405020304" pitchFamily="18" charset="0"/>
+              </a:rPr>
+              <a:t>Por </a:t>
+            </a:r>
+            <a:r>
+              <a:rPr lang="es-ES" sz="1200" dirty="0">
+                <a:latin typeface="Times New Roman" panose="02020603050405020304" pitchFamily="18" charset="0"/>
+                <a:cs typeface="Times New Roman" panose="02020603050405020304" pitchFamily="18" charset="0"/>
+              </a:rPr>
+              <a:t>ejemplo:</a:t>
+            </a:r>
+          </a:p>
+          <a:p>
+            <a:endParaRPr lang="es-ES" sz="1200" dirty="0">
+              <a:latin typeface="Times New Roman" panose="02020603050405020304" pitchFamily="18" charset="0"/>
+              <a:cs typeface="Times New Roman" panose="02020603050405020304" pitchFamily="18" charset="0"/>
+            </a:endParaRPr>
+          </a:p>
+          <a:p>
+            <a:pPr marL="171450" indent="-171450">
+              <a:spcBef>
+                <a:spcPts val="600"/>
+              </a:spcBef>
+              <a:buFont typeface="Arial" panose="020B0604020202020204" pitchFamily="34" charset="0"/>
+              <a:buChar char="•"/>
+            </a:pPr>
+            <a:r>
+              <a:rPr lang="es-ES" sz="1200" dirty="0" smtClean="0">
+                <a:latin typeface="Times New Roman" panose="02020603050405020304" pitchFamily="18" charset="0"/>
+                <a:cs typeface="Times New Roman" panose="02020603050405020304" pitchFamily="18" charset="0"/>
+              </a:rPr>
+              <a:t>Desde </a:t>
+            </a:r>
+            <a:r>
+              <a:rPr lang="es-ES" sz="1200" dirty="0">
+                <a:latin typeface="Times New Roman" panose="02020603050405020304" pitchFamily="18" charset="0"/>
+                <a:cs typeface="Times New Roman" panose="02020603050405020304" pitchFamily="18" charset="0"/>
+              </a:rPr>
+              <a:t>el punto de vista financiero, una inversión se paga en su totalidad en el momento en que se realiza.</a:t>
+            </a:r>
+          </a:p>
+          <a:p>
+            <a:pPr marL="171450" indent="-171450">
+              <a:spcBef>
+                <a:spcPts val="600"/>
+              </a:spcBef>
+              <a:buFont typeface="Arial" panose="020B0604020202020204" pitchFamily="34" charset="0"/>
+              <a:buChar char="•"/>
+            </a:pPr>
+            <a:r>
+              <a:rPr lang="es-ES" sz="1200" dirty="0" smtClean="0">
+                <a:latin typeface="Times New Roman" panose="02020603050405020304" pitchFamily="18" charset="0"/>
+                <a:cs typeface="Times New Roman" panose="02020603050405020304" pitchFamily="18" charset="0"/>
+              </a:rPr>
+              <a:t>Desde </a:t>
+            </a:r>
+            <a:r>
+              <a:rPr lang="es-ES" sz="1200" dirty="0">
+                <a:latin typeface="Times New Roman" panose="02020603050405020304" pitchFamily="18" charset="0"/>
+                <a:cs typeface="Times New Roman" panose="02020603050405020304" pitchFamily="18" charset="0"/>
+              </a:rPr>
+              <a:t>el punto de vista contable, esa inversión se "guarda" en una cuenta (sin afectar a beneficios) y se va amortizando progresivamente (reduciendo beneficios) a lo largo de varios años.</a:t>
+            </a:r>
+          </a:p>
+          <a:p>
+            <a:endParaRPr lang="es-ES" sz="1200" dirty="0">
+              <a:latin typeface="Times New Roman" panose="02020603050405020304" pitchFamily="18" charset="0"/>
+              <a:cs typeface="Times New Roman" panose="02020603050405020304" pitchFamily="18" charset="0"/>
+            </a:endParaRPr>
+          </a:p>
+          <a:p>
+            <a:pPr marL="171450" indent="-171450">
+              <a:spcBef>
+                <a:spcPts val="600"/>
+              </a:spcBef>
+              <a:buFont typeface="Arial" panose="020B0604020202020204" pitchFamily="34" charset="0"/>
+              <a:buChar char="•"/>
+            </a:pPr>
+            <a:r>
+              <a:rPr lang="es-ES" sz="1200" dirty="0" smtClean="0">
+                <a:latin typeface="Times New Roman" panose="02020603050405020304" pitchFamily="18" charset="0"/>
+                <a:cs typeface="Times New Roman" panose="02020603050405020304" pitchFamily="18" charset="0"/>
+              </a:rPr>
+              <a:t>Desde </a:t>
+            </a:r>
+            <a:r>
+              <a:rPr lang="es-ES" sz="1200" dirty="0">
+                <a:latin typeface="Times New Roman" panose="02020603050405020304" pitchFamily="18" charset="0"/>
+                <a:cs typeface="Times New Roman" panose="02020603050405020304" pitchFamily="18" charset="0"/>
+              </a:rPr>
+              <a:t>el punto de vista financiero, un resultado de pérdidas se produce en el día, mes o año en que </a:t>
+            </a:r>
+            <a:r>
+              <a:rPr lang="es-ES" sz="1200">
+                <a:latin typeface="Times New Roman" panose="02020603050405020304" pitchFamily="18" charset="0"/>
+                <a:cs typeface="Times New Roman" panose="02020603050405020304" pitchFamily="18" charset="0"/>
+              </a:rPr>
+              <a:t>se </a:t>
+            </a:r>
+            <a:r>
+              <a:rPr lang="es-ES" sz="1200" smtClean="0">
+                <a:latin typeface="Times New Roman" panose="02020603050405020304" pitchFamily="18" charset="0"/>
+                <a:cs typeface="Times New Roman" panose="02020603050405020304" pitchFamily="18" charset="0"/>
+              </a:rPr>
+              <a:t>calcula </a:t>
+            </a:r>
+            <a:r>
+              <a:rPr lang="es-ES" sz="1200" dirty="0">
+                <a:latin typeface="Times New Roman" panose="02020603050405020304" pitchFamily="18" charset="0"/>
+                <a:cs typeface="Times New Roman" panose="02020603050405020304" pitchFamily="18" charset="0"/>
+              </a:rPr>
+              <a:t>(ingresos - </a:t>
+            </a:r>
+            <a:r>
+              <a:rPr lang="es-ES" sz="1200" dirty="0" err="1">
+                <a:latin typeface="Times New Roman" panose="02020603050405020304" pitchFamily="18" charset="0"/>
+                <a:cs typeface="Times New Roman" panose="02020603050405020304" pitchFamily="18" charset="0"/>
+              </a:rPr>
+              <a:t>gastos|inversiones</a:t>
+            </a:r>
+            <a:r>
+              <a:rPr lang="es-ES" sz="1200" dirty="0">
+                <a:latin typeface="Times New Roman" panose="02020603050405020304" pitchFamily="18" charset="0"/>
+                <a:cs typeface="Times New Roman" panose="02020603050405020304" pitchFamily="18" charset="0"/>
+              </a:rPr>
+              <a:t>).</a:t>
+            </a:r>
+          </a:p>
+          <a:p>
+            <a:pPr marL="171450" indent="-171450">
+              <a:spcBef>
+                <a:spcPts val="600"/>
+              </a:spcBef>
+              <a:buFont typeface="Arial" panose="020B0604020202020204" pitchFamily="34" charset="0"/>
+              <a:buChar char="•"/>
+            </a:pPr>
+            <a:r>
+              <a:rPr lang="es-ES" sz="1200" dirty="0" smtClean="0">
+                <a:latin typeface="Times New Roman" panose="02020603050405020304" pitchFamily="18" charset="0"/>
+                <a:cs typeface="Times New Roman" panose="02020603050405020304" pitchFamily="18" charset="0"/>
+              </a:rPr>
+              <a:t>Desde </a:t>
+            </a:r>
+            <a:r>
+              <a:rPr lang="es-ES" sz="1200" dirty="0">
+                <a:latin typeface="Times New Roman" panose="02020603050405020304" pitchFamily="18" charset="0"/>
+                <a:cs typeface="Times New Roman" panose="02020603050405020304" pitchFamily="18" charset="0"/>
+              </a:rPr>
+              <a:t>el punto de vista contable, esas pérdidas se "guardan" en una cuenta desde la que se pueden compensar ganancias en los años venideros para pagar menos impuestos en esos otros años.</a:t>
+            </a:r>
+          </a:p>
+          <a:p>
+            <a:endParaRPr lang="es-ES" sz="1200" dirty="0">
+              <a:latin typeface="Times New Roman" panose="02020603050405020304" pitchFamily="18" charset="0"/>
+              <a:cs typeface="Times New Roman" panose="02020603050405020304" pitchFamily="18" charset="0"/>
+            </a:endParaRPr>
+          </a:p>
+          <a:p>
+            <a:endParaRPr lang="es-ES" sz="1200" dirty="0">
+              <a:latin typeface="Times New Roman" panose="02020603050405020304" pitchFamily="18" charset="0"/>
+              <a:cs typeface="Times New Roman" panose="02020603050405020304" pitchFamily="18" charset="0"/>
+            </a:endParaRPr>
+          </a:p>
+          <a:p>
+            <a:endParaRPr lang="es-ES" sz="1200" dirty="0">
+              <a:latin typeface="Times New Roman" panose="02020603050405020304" pitchFamily="18" charset="0"/>
+              <a:cs typeface="Times New Roman" panose="02020603050405020304" pitchFamily="18" charset="0"/>
+            </a:endParaRPr>
+          </a:p>
+        </p:txBody>
+      </p:sp>
+    </p:spTree>
+    <p:extLst>
+      <p:ext uri="{BB962C8B-B14F-4D97-AF65-F5344CB8AC3E}">
+        <p14:creationId xmlns:p14="http://schemas.microsoft.com/office/powerpoint/2010/main" val="2352049794"/>
       </p:ext>
     </p:extLst>
   </p:cSld>

</xml_diff>